<commit_message>
Add Send to Billing (US-04)
A served patient can be sent from their department to a new Billing
queue in one click: the visit is completed, a linked billing token
(B001...) is issued with the same patient details, the staff console
shows where it came from, the display shows the Billing queue, and the
patient's token page shows their billing number.

Tests first: 6 unit and 5 browser tests (25 unit, 23 browser, all pass).
Docs and the demo deck's cut list updated.

Co-Authored-By: Claude Opus 5.5 <noreply@anthropic.com>
Claude-Session: https://claude.ai/code/session_0121RppEMiZwfp7AxntpwJk5
</commit_message>
<xml_diff>
--- a/docs/deck/CareQueue_Team12_Demo_Deck.pptx
+++ b/docs/deck/CareQueue_Team12_Demo_Deck.pptx
@@ -638,7 +638,7 @@
           <a:lstStyle/>
           <a:p>
             <a:r>
-              <a:t>About 20 seconds. We built our three PRD Must-Haves: ordered digital tokens, Call Next with a live Now-Serving display, and a wait estimate that learns from real service times. The display updates in under 2 seconds; we measured 28 ms, and 37 automated tests pass. We cut a server and database, QR phone tracking and Send to Billing on purpose, to finish a working demo in 1.5 days.</a:t>
+              <a:t>About 20 seconds. We built our three PRD Must-Haves: ordered digital tokens, Call Next with a live Now-Serving display, and a wait estimate that learns from real service times. The display updates in under 2 seconds; we measured 28 ms, and 37 automated tests pass. We cut a server and database, QR phone tracking and voice announcements on purpose, to finish a working demo in 1.5 days. We also added Send to Billing, so a patient moves from their department straight into the Billing queue.</a:t>
             </a:r>
           </a:p>
         </p:txBody>
@@ -724,7 +724,7 @@
           <a:lstStyle/>
           <a:p>
             <a:r>
-              <a:t>About two minutes. Ashik drives, Sam narrates. 1) Sign in as a patient and get a token. 2) Sign out, sign in as receptionist with PIN 1234, press Call Next. 3) Open the display: the token is now serving, the next tokens show their wait. 4) Skip and Recall. Note: one browser holds one sign-in at a time. If the live app fails, play CareQueue-backup-demo.webm (in docs/demo of our repo) straight away.</a:t>
+              <a:t>About two minutes. Ashik drives, Sam narrates. 1) Sign in as a patient and get a token. 2) Sign out, sign in as receptionist with PIN 1234, press Call Next. 3) Open the display: the token is now serving, the next tokens show their wait. 4) Skip and Recall. 5) Send a served patient to Billing and show the new B token on the display. Note: one browser holds one sign-in at a time. If the live app fails, play CareQueue-backup-demo.webm (in docs/demo of our repo) straight away.</a:t>
             </a:r>
           </a:p>
         </p:txBody>
@@ -4024,7 +4024,7 @@
                 <a:ea typeface="Arial" pitchFamily="34" charset="-122"/>
                 <a:cs typeface="Arial" pitchFamily="34" charset="-120"/>
               </a:rPr>
-              <a:t>Send to Billing — one queue per department is clearer</a:t>
+              <a:t>Voice announcement — the large display carries the call</a:t>
             </a:r>
             <a:endParaRPr lang="en-US" sz="1400" dirty="0"/>
           </a:p>

</xml_diff>

<commit_message>
Add voice announcements on the waiting-room display (US-08)
A Turn on sound switch on the display (browsers block sound until a
click). Each call, and each recall of the same token, plays a chime and
says e.g. 'Token G 0 0 1, please come to General Medicine.' Opening the
display announces nothing; names are never spoken; announcements play
one at a time.

frontend/js/announce.js holds the rules (unit-tested) and the browser
audio; display.js detects new calls from token number + call time.
Also restores two test lines lost in the merge of main into this branch.

Tests: unit 34/34 (9 new), backend 11/11, e2e 30/30 (4 new), 3 runs.
Deck slide 4 cut list updated (voice announcement is built now).

Co-Authored-By: Claude Opus 5.5 <noreply@anthropic.com>
Claude-Session: https://claude.ai/code/session_0121RppEMiZwfp7AxntpwJk5
</commit_message>
<xml_diff>
--- a/docs/deck/CareQueue_Team12_Demo_Deck.pptx
+++ b/docs/deck/CareQueue_Team12_Demo_Deck.pptx
@@ -638,7 +638,7 @@
           <a:lstStyle/>
           <a:p>
             <a:r>
-              <a:t>About 20 seconds. We built our three PRD Must-Haves: ordered digital tokens, Call Next with a live Now-Serving display, and a wait estimate that learns from real service times. The display updates in under 2 seconds; across 10 calls we measured at most 0.7 seconds, and 60 automated tests pass. We cut multiple counters, QR phone tracking and voice announcements on purpose, to finish a working demo in 1.5 days. The queue runs on a Flask server with an SQLite database. We also added Send to Billing, so a patient moves from their department straight into the Billing queue.</a:t>
+              <a:t>About 20 seconds. We built our three PRD Must-Haves: ordered digital tokens, Call Next with a live Now-Serving display, and a wait estimate that learns from real service times. The display updates in under 2 seconds; across 10 calls we measured at most 0.7 seconds, and 60 automated tests pass. We cut multiple counters, QR phone tracking and online booking on purpose, to finish a working demo in 1.5 days. The queue runs on a Flask server with an SQLite database. We also added Send to Billing, so a patient moves from their department straight into the Billing queue.</a:t>
             </a:r>
           </a:p>
         </p:txBody>
@@ -724,7 +724,7 @@
           <a:lstStyle/>
           <a:p>
             <a:r>
-              <a:t>About two minutes. Ashik drives, Sam narrates. 1) Sign in as a patient and get a token. 2) Sign out, sign in as receptionist with PIN 1234, press Call Next. 3) Open the display: the token is now serving, the next tokens show their wait. 4) Skip and Recall. 5) Send a served patient to Billing and show the new B token on the display. Start the app first with npm start and open http://127.0.0.1:8000. Note: one browser holds one sign-in at a time. If the live app fails, play CareQueue-backup-demo.webm (in docs/demo of our repo) straight away.</a:t>
+              <a:t>About two minutes. Ashik drives, Sam narrates. 1) Sign in as a patient and get a token. 2) Sign out, sign in as receptionist with PIN 1234, press Call Next. 3) Open the display: the token is now serving, the next tokens show their wait. 4) Skip and Recall. 5) Send a served patient to Billing and show the new B token on the display. 6) Press Turn on sound on the display, then Call Next: it chimes and says the token and department. Start the app first with npm start and open http://127.0.0.1:8000. Note: one browser holds one sign-in at a time. If the live app fails, play CareQueue-backup-demo.webm (in docs/demo of our repo) straight away.</a:t>
             </a:r>
           </a:p>
         </p:txBody>
@@ -4024,7 +4024,7 @@
                 <a:ea typeface="Arial" pitchFamily="34" charset="-122"/>
                 <a:cs typeface="Arial" pitchFamily="34" charset="-120"/>
               </a:rPr>
-              <a:t>Voice announcement — the large display carries the call</a:t>
+              <a:t>Online booking from home — walk-in patients come first</a:t>
             </a:r>
             <a:endParaRPr lang="en-US" sz="1400" dirty="0"/>
           </a:p>

</xml_diff>